<commit_message>
Regenerate the Phase 2 report and deck
Co-Authored-By: Claude Opus 5.5 <noreply@anthropic.com>
Claude-Session: https://claude.ai/code/session_01UCp4tCsv3VTemVhf2jiRBm
</commit_message>
<xml_diff>
--- a/submission/phase2/OrchLang_Phase2_Presentation_Nambi_Rajan_M.pptx
+++ b/submission/phase2/OrchLang_Phase2_Presentation_Nambi_Rajan_M.pptx
@@ -1137,7 +1137,7 @@
           <a:p>
             <a:r>
               <a:rPr lang="en-US" dirty="0"/>
-              <a:t>I ported thirty real workflows under a protocol I fixed in advance: labels first, then development ports, then the compiler frozen, then held-out ports checked once. No bound was exceeded, no labelled flow error was missed, and the checker over-reported twice. And none of the sources had a secret, so the analysis this talk is about found nothing to check on real code. I say that plainly because it is the most important limitation.</a:t>
+              <a:t>I ported thirty real workflows under a protocol I fixed in advance: labels first, then development ports, then the compiler frozen, then held-out ports checked once. No bound was exceeded, no labelled flow error was missed, and the checker over-reported twice. AgentDojo publishes its recorded attacks: all 88 that succeeded on these tasks made calls outside the fixed plan, so it is the plan, not my checker, that stops them; the checker marks where an attacker could still steer the planned calls. And none of the sources had a secret, so the analysis this talk is about found nothing to check on real code. I say that plainly because it is the most important limitation.</a:t>
             </a:r>
             <a:endParaRPr lang="en-US" dirty="0"/>
           </a:p>
@@ -11224,7 +11224,7 @@
                 <a:ea typeface="Calibri" pitchFamily="34" charset="-122"/>
                 <a:cs typeface="Calibri" pitchFamily="34" charset="-120"/>
               </a:rPr>
-              <a:t>Up to 25x the estimate, unless a model declares a byte cap.</a:t>
+              <a:t>4x the estimate on real workflows, up to 128x when requests carry earlier answers, unless a model declares a byte cap.</a:t>
             </a:r>
             <a:endParaRPr lang="en-US" sz="1200" dirty="0"/>
           </a:p>

</xml_diff>